<commit_message>
Clean up ADIB presentation text
Co-authored-by: Amr Essam <amressam93@users.noreply.github.com>
</commit_message>
<xml_diff>
--- a/presentation/adib_card_deck/ADIB_Card_Portfolio_Presentation.pptx
+++ b/presentation/adib_card_deck/ADIB_Card_Portfolio_Presentation.pptx
@@ -4333,76 +4333,6 @@
       </p:pic>
       <p:sp>
         <p:nvSpPr>
-          <p:cNvPr id="3" name="TextBox 2"/>
-          <p:cNvSpPr txBox="1"/>
-          <p:nvPr/>
-        </p:nvSpPr>
-        <p:spPr>
-          <a:xfrm>
-            <a:off x="594360" y="402336"/>
-            <a:ext cx="7589520" cy="502920"/>
-          </a:xfrm>
-          <a:prstGeom prst="rect">
-            <a:avLst/>
-          </a:prstGeom>
-          <a:noFill/>
-        </p:spPr>
-        <p:txBody>
-          <a:bodyPr wrap="none" lIns="0" rIns="0" tIns="0" bIns="0" anchor="t">
-            <a:spAutoFit/>
-          </a:bodyPr>
-          <a:lstStyle/>
-          <a:p>
-            <a:pPr algn="l"/>
-            <a:r>
-              <a:rPr sz="3000" b="1">
-                <a:solidFill>
-                  <a:srgbClr val="002455"/>
-                </a:solidFill>
-                <a:latin typeface="Aptos"/>
-              </a:rPr>
-              <a:t>Key benefits</a:t>
-            </a:r>
-          </a:p>
-        </p:txBody>
-      </p:sp>
-      <p:sp>
-        <p:nvSpPr>
-          <p:cNvPr id="4" name="TextBox 3"/>
-          <p:cNvSpPr txBox="1"/>
-          <p:nvPr/>
-        </p:nvSpPr>
-        <p:spPr>
-          <a:xfrm>
-            <a:off x="612648" y="941832"/>
-            <a:ext cx="7132320" cy="329184"/>
-          </a:xfrm>
-          <a:prstGeom prst="rect">
-            <a:avLst/>
-          </a:prstGeom>
-          <a:noFill/>
-        </p:spPr>
-        <p:txBody>
-          <a:bodyPr wrap="none" lIns="0" rIns="0" tIns="0" bIns="0" anchor="t">
-            <a:spAutoFit/>
-          </a:bodyPr>
-          <a:lstStyle/>
-          <a:p>
-            <a:pPr algn="l"/>
-            <a:r>
-              <a:rPr sz="1300" b="0">
-                <a:solidFill>
-                  <a:srgbClr val="5C6C7C"/>
-                </a:solidFill>
-                <a:latin typeface="Aptos"/>
-              </a:rPr>
-              <a:t>Designed for simple, confident everyday payments.</a:t>
-            </a:r>
-          </a:p>
-        </p:txBody>
-      </p:sp>
-      <p:sp>
-        <p:nvSpPr>
           <p:cNvPr id="5" name="Rectangle 4"/>
           <p:cNvSpPr/>
           <p:nvPr/>
@@ -6286,7 +6216,7 @@
                 </a:solidFill>
                 <a:latin typeface="DejaVu Sans"/>
               </a:rPr>
-              <a:t>✓</a:t>
+              <a:t>+</a:t>
             </a:r>
           </a:p>
         </p:txBody>
@@ -6373,7 +6303,7 @@
                 </a:solidFill>
                 <a:latin typeface="DejaVu Sans"/>
               </a:rPr>
-              <a:t>✓</a:t>
+              <a:t>+</a:t>
             </a:r>
           </a:p>
         </p:txBody>
@@ -6460,7 +6390,7 @@
                 </a:solidFill>
                 <a:latin typeface="DejaVu Sans"/>
               </a:rPr>
-              <a:t>✓</a:t>
+              <a:t>+</a:t>
             </a:r>
           </a:p>
         </p:txBody>
@@ -6547,7 +6477,7 @@
                 </a:solidFill>
                 <a:latin typeface="DejaVu Sans"/>
               </a:rPr>
-              <a:t>✓</a:t>
+              <a:t>+</a:t>
             </a:r>
           </a:p>
         </p:txBody>

</xml_diff>